<commit_message>
Fine-tune kerning coefficient to 0.01200
</commit_message>
<xml_diff>
--- a/gallery/renders/title_body_basic.pptx
+++ b/gallery/renders/title_body_basic.pptx
@@ -35,7 +35,7 @@
         <p:spPr>
           <a:xfrm>
             <a:off x="910336" y="2092147"/>
-            <a:ext cx="11184128" cy="731520"/>
+            <a:ext cx="11184128" cy="746760"/>
           </a:xfrm>
           <a:prstGeom prst="rect">
             <a:avLst/>
@@ -80,7 +80,7 @@
         <p:spPr>
           <a:xfrm>
             <a:off x="910336" y="687628"/>
-            <a:ext cx="11184128" cy="609600"/>
+            <a:ext cx="11184128" cy="609599"/>
           </a:xfrm>
           <a:prstGeom prst="rect">
             <a:avLst/>

</xml_diff>